<commit_message>
chore(assets): rename slide template to template.pptx and update docker config
Remove the -en language suffix from the template filename for a language-neutral
naming convention. Update SLIDE_TEMPLATE_PATH in docker-compose.yml to match.
</commit_message>
<xml_diff>
--- a/assets/pptx-template.pptx
+++ b/assets/pptx-template.pptx
@@ -1183,7 +1183,7 @@
 
 <file path=ppt/slideLayouts/slideLayout1.xml><?xml version="1.0" encoding="utf-8"?>
 <p:sldLayout xmlns:a="http://schemas.openxmlformats.org/drawingml/2006/main" xmlns:r="http://schemas.openxmlformats.org/officeDocument/2006/relationships" xmlns:mc="http://schemas.openxmlformats.org/markup-compatibility/2006" xmlns:mv="urn:schemas-microsoft-com:mac:vml" xmlns:p="http://schemas.openxmlformats.org/presentationml/2006/main" xmlns:c="http://schemas.openxmlformats.org/drawingml/2006/chart" xmlns:dgm="http://schemas.openxmlformats.org/drawingml/2006/diagram" xmlns:o="urn:schemas-microsoft-com:office:office" xmlns:v="urn:schemas-microsoft-com:vml" xmlns:pvml="urn:schemas-microsoft-com:office:powerpoint" xmlns:com="http://schemas.openxmlformats.org/drawingml/2006/compatibility" xmlns:p14="http://schemas.microsoft.com/office/powerpoint/2010/main" xmlns:p15="http://schemas.microsoft.com/office/powerpoint/2012/main" xmlns:ahyp="http://schemas.microsoft.com/office/drawing/2018/hyperlinkcolor" matchingName="標題與副標題" type="title">
-  <p:cSld name="TITLE">
+  <p:cSld name="TITLE_SLIDE">
     <p:spTree>
       <p:nvGrpSpPr>
         <p:cNvPr id="9" name="Shape 9"/>
@@ -2361,7 +2361,7 @@
 
 <file path=ppt/slideLayouts/slideLayout10.xml><?xml version="1.0" encoding="utf-8"?>
 <p:sldLayout xmlns:a="http://schemas.openxmlformats.org/drawingml/2006/main" xmlns:r="http://schemas.openxmlformats.org/officeDocument/2006/relationships" xmlns:mc="http://schemas.openxmlformats.org/markup-compatibility/2006" xmlns:mv="urn:schemas-microsoft-com:mac:vml" xmlns:p="http://schemas.openxmlformats.org/presentationml/2006/main" xmlns:c="http://schemas.openxmlformats.org/drawingml/2006/chart" xmlns:dgm="http://schemas.openxmlformats.org/drawingml/2006/diagram" xmlns:o="urn:schemas-microsoft-com:office:office" xmlns:v="urn:schemas-microsoft-com:vml" xmlns:pvml="urn:schemas-microsoft-com:office:powerpoint" xmlns:com="http://schemas.openxmlformats.org/drawingml/2006/compatibility" xmlns:p14="http://schemas.microsoft.com/office/powerpoint/2010/main" xmlns:p15="http://schemas.microsoft.com/office/powerpoint/2012/main" xmlns:ahyp="http://schemas.microsoft.com/office/drawing/2018/hyperlinkcolor" matchingName="照片 - 一頁三張">
-  <p:cSld name="照片 - 一頁三張">
+  <p:cSld name="THREE_PHOTO">
     <p:spTree>
       <p:nvGrpSpPr>
         <p:cNvPr id="101" name="Shape 101"/>
@@ -2659,7 +2659,7 @@
 
 <file path=ppt/slideLayouts/slideLayout11.xml><?xml version="1.0" encoding="utf-8"?>
 <p:sldLayout xmlns:a="http://schemas.openxmlformats.org/drawingml/2006/main" xmlns:r="http://schemas.openxmlformats.org/officeDocument/2006/relationships" xmlns:mc="http://schemas.openxmlformats.org/markup-compatibility/2006" xmlns:mv="urn:schemas-microsoft-com:mac:vml" xmlns:p="http://schemas.openxmlformats.org/presentationml/2006/main" xmlns:c="http://schemas.openxmlformats.org/drawingml/2006/chart" xmlns:dgm="http://schemas.openxmlformats.org/drawingml/2006/diagram" xmlns:o="urn:schemas-microsoft-com:office:office" xmlns:v="urn:schemas-microsoft-com:vml" xmlns:pvml="urn:schemas-microsoft-com:office:powerpoint" xmlns:com="http://schemas.openxmlformats.org/drawingml/2006/compatibility" xmlns:p14="http://schemas.microsoft.com/office/powerpoint/2010/main" xmlns:p15="http://schemas.microsoft.com/office/powerpoint/2012/main" xmlns:ahyp="http://schemas.microsoft.com/office/drawing/2018/hyperlinkcolor" matchingName="照片">
-  <p:cSld name="照片">
+  <p:cSld name="FULL_PHOTO">
     <p:spTree>
       <p:nvGrpSpPr>
         <p:cNvPr id="106" name="Shape 106"/>
@@ -2913,7 +2913,7 @@
 
 <file path=ppt/slideLayouts/slideLayout12.xml><?xml version="1.0" encoding="utf-8"?>
 <p:sldLayout xmlns:a="http://schemas.openxmlformats.org/drawingml/2006/main" xmlns:r="http://schemas.openxmlformats.org/officeDocument/2006/relationships" xmlns:mc="http://schemas.openxmlformats.org/markup-compatibility/2006" xmlns:mv="urn:schemas-microsoft-com:mac:vml" xmlns:p="http://schemas.openxmlformats.org/presentationml/2006/main" xmlns:c="http://schemas.openxmlformats.org/drawingml/2006/chart" xmlns:dgm="http://schemas.openxmlformats.org/drawingml/2006/diagram" xmlns:o="urn:schemas-microsoft-com:office:office" xmlns:v="urn:schemas-microsoft-com:vml" xmlns:pvml="urn:schemas-microsoft-com:office:powerpoint" xmlns:com="http://schemas.openxmlformats.org/drawingml/2006/compatibility" xmlns:p14="http://schemas.microsoft.com/office/powerpoint/2010/main" xmlns:p15="http://schemas.microsoft.com/office/powerpoint/2012/main" xmlns:ahyp="http://schemas.microsoft.com/office/drawing/2018/hyperlinkcolor" matchingName="空白">
-  <p:cSld name="空白">
+  <p:cSld name="BLANK">
     <p:spTree>
       <p:nvGrpSpPr>
         <p:cNvPr id="109" name="Shape 109"/>
@@ -4411,7 +4411,7 @@
 
 <file path=ppt/slideLayouts/slideLayout3.xml><?xml version="1.0" encoding="utf-8"?>
 <p:sldLayout xmlns:a="http://schemas.openxmlformats.org/drawingml/2006/main" xmlns:r="http://schemas.openxmlformats.org/officeDocument/2006/relationships" xmlns:mc="http://schemas.openxmlformats.org/markup-compatibility/2006" xmlns:mv="urn:schemas-microsoft-com:mac:vml" xmlns:p="http://schemas.openxmlformats.org/presentationml/2006/main" xmlns:c="http://schemas.openxmlformats.org/drawingml/2006/chart" xmlns:dgm="http://schemas.openxmlformats.org/drawingml/2006/diagram" xmlns:o="urn:schemas-microsoft-com:office:office" xmlns:v="urn:schemas-microsoft-com:vml" xmlns:pvml="urn:schemas-microsoft-com:office:powerpoint" xmlns:com="http://schemas.openxmlformats.org/drawingml/2006/compatibility" xmlns:p14="http://schemas.microsoft.com/office/powerpoint/2010/main" xmlns:p15="http://schemas.microsoft.com/office/powerpoint/2012/main" xmlns:ahyp="http://schemas.microsoft.com/office/drawing/2018/hyperlinkcolor" matchingName="名言語錄">
-  <p:cSld name="名言語錄">
+  <p:cSld name="QUOTE">
     <p:spTree>
       <p:nvGrpSpPr>
         <p:cNvPr id="36" name="Shape 36"/>
@@ -6095,7 +6095,7 @@
 
 <file path=ppt/slideLayouts/slideLayout4.xml><?xml version="1.0" encoding="utf-8"?>
 <p:sldLayout xmlns:a="http://schemas.openxmlformats.org/drawingml/2006/main" xmlns:r="http://schemas.openxmlformats.org/officeDocument/2006/relationships" xmlns:mc="http://schemas.openxmlformats.org/markup-compatibility/2006" xmlns:mv="urn:schemas-microsoft-com:mac:vml" xmlns:p="http://schemas.openxmlformats.org/presentationml/2006/main" xmlns:c="http://schemas.openxmlformats.org/drawingml/2006/chart" xmlns:dgm="http://schemas.openxmlformats.org/drawingml/2006/diagram" xmlns:o="urn:schemas-microsoft-com:office:office" xmlns:v="urn:schemas-microsoft-com:vml" xmlns:pvml="urn:schemas-microsoft-com:office:powerpoint" xmlns:com="http://schemas.openxmlformats.org/drawingml/2006/compatibility" xmlns:p14="http://schemas.microsoft.com/office/powerpoint/2010/main" xmlns:p15="http://schemas.microsoft.com/office/powerpoint/2012/main" xmlns:ahyp="http://schemas.microsoft.com/office/drawing/2018/hyperlinkcolor" matchingName="照片 - 水平">
-  <p:cSld name="照片 - 水平">
+  <p:cSld name="PHOTO_LANDSCAPE">
     <p:spTree>
       <p:nvGrpSpPr>
         <p:cNvPr id="58" name="Shape 58"/>
@@ -6721,7 +6721,7 @@
 
 <file path=ppt/slideLayouts/slideLayout5.xml><?xml version="1.0" encoding="utf-8"?>
 <p:sldLayout xmlns:a="http://schemas.openxmlformats.org/drawingml/2006/main" xmlns:r="http://schemas.openxmlformats.org/officeDocument/2006/relationships" xmlns:mc="http://schemas.openxmlformats.org/markup-compatibility/2006" xmlns:mv="urn:schemas-microsoft-com:mac:vml" xmlns:p="http://schemas.openxmlformats.org/presentationml/2006/main" xmlns:c="http://schemas.openxmlformats.org/drawingml/2006/chart" xmlns:dgm="http://schemas.openxmlformats.org/drawingml/2006/diagram" xmlns:o="urn:schemas-microsoft-com:office:office" xmlns:v="urn:schemas-microsoft-com:vml" xmlns:pvml="urn:schemas-microsoft-com:office:powerpoint" xmlns:com="http://schemas.openxmlformats.org/drawingml/2006/compatibility" xmlns:p14="http://schemas.microsoft.com/office/powerpoint/2010/main" xmlns:p15="http://schemas.microsoft.com/office/powerpoint/2012/main" xmlns:ahyp="http://schemas.microsoft.com/office/drawing/2018/hyperlinkcolor" matchingName="標題 - 中央">
-  <p:cSld name="標題 - 中央">
+  <p:cSld name="SECTION_HEADER_CENTER">
     <p:spTree>
       <p:nvGrpSpPr>
         <p:cNvPr id="63" name="Shape 63"/>
@@ -7137,7 +7137,7 @@
 
 <file path=ppt/slideLayouts/slideLayout6.xml><?xml version="1.0" encoding="utf-8"?>
 <p:sldLayout xmlns:a="http://schemas.openxmlformats.org/drawingml/2006/main" xmlns:r="http://schemas.openxmlformats.org/officeDocument/2006/relationships" xmlns:mc="http://schemas.openxmlformats.org/markup-compatibility/2006" xmlns:mv="urn:schemas-microsoft-com:mac:vml" xmlns:p="http://schemas.openxmlformats.org/presentationml/2006/main" xmlns:c="http://schemas.openxmlformats.org/drawingml/2006/chart" xmlns:dgm="http://schemas.openxmlformats.org/drawingml/2006/diagram" xmlns:o="urn:schemas-microsoft-com:office:office" xmlns:v="urn:schemas-microsoft-com:vml" xmlns:pvml="urn:schemas-microsoft-com:office:powerpoint" xmlns:com="http://schemas.openxmlformats.org/drawingml/2006/compatibility" xmlns:p14="http://schemas.microsoft.com/office/powerpoint/2010/main" xmlns:p15="http://schemas.microsoft.com/office/powerpoint/2012/main" xmlns:ahyp="http://schemas.microsoft.com/office/drawing/2018/hyperlinkcolor" matchingName="照片 - 直式">
-  <p:cSld name="照片 - 直式">
+  <p:cSld name="PHOTO_PORTRAIT">
     <p:spTree>
       <p:nvGrpSpPr>
         <p:cNvPr id="66" name="Shape 66"/>
@@ -7787,7 +7787,7 @@
 
 <file path=ppt/slideLayouts/slideLayout7.xml><?xml version="1.0" encoding="utf-8"?>
 <p:sldLayout xmlns:a="http://schemas.openxmlformats.org/drawingml/2006/main" xmlns:r="http://schemas.openxmlformats.org/officeDocument/2006/relationships" xmlns:mc="http://schemas.openxmlformats.org/markup-compatibility/2006" xmlns:mv="urn:schemas-microsoft-com:mac:vml" xmlns:p="http://schemas.openxmlformats.org/presentationml/2006/main" xmlns:c="http://schemas.openxmlformats.org/drawingml/2006/chart" xmlns:dgm="http://schemas.openxmlformats.org/drawingml/2006/diagram" xmlns:o="urn:schemas-microsoft-com:office:office" xmlns:v="urn:schemas-microsoft-com:vml" xmlns:pvml="urn:schemas-microsoft-com:office:powerpoint" xmlns:com="http://schemas.openxmlformats.org/drawingml/2006/compatibility" xmlns:p14="http://schemas.microsoft.com/office/powerpoint/2010/main" xmlns:p15="http://schemas.microsoft.com/office/powerpoint/2012/main" xmlns:ahyp="http://schemas.microsoft.com/office/drawing/2018/hyperlinkcolor" matchingName="標題 - 上方">
-  <p:cSld name="標題 - 上方">
+  <p:cSld name="SECTION_HEADER_TOP">
     <p:spTree>
       <p:nvGrpSpPr>
         <p:cNvPr id="71" name="Shape 71"/>
@@ -8202,7 +8202,7 @@
 
 <file path=ppt/slideLayouts/slideLayout8.xml><?xml version="1.0" encoding="utf-8"?>
 <p:sldLayout xmlns:a="http://schemas.openxmlformats.org/drawingml/2006/main" xmlns:r="http://schemas.openxmlformats.org/officeDocument/2006/relationships" xmlns:mc="http://schemas.openxmlformats.org/markup-compatibility/2006" xmlns:mv="urn:schemas-microsoft-com:mac:vml" xmlns:p="http://schemas.openxmlformats.org/presentationml/2006/main" xmlns:c="http://schemas.openxmlformats.org/drawingml/2006/chart" xmlns:dgm="http://schemas.openxmlformats.org/drawingml/2006/diagram" xmlns:o="urn:schemas-microsoft-com:office:office" xmlns:v="urn:schemas-microsoft-com:vml" xmlns:pvml="urn:schemas-microsoft-com:office:powerpoint" xmlns:com="http://schemas.openxmlformats.org/drawingml/2006/compatibility" xmlns:p14="http://schemas.microsoft.com/office/powerpoint/2010/main" xmlns:p15="http://schemas.microsoft.com/office/powerpoint/2012/main" xmlns:ahyp="http://schemas.microsoft.com/office/drawing/2018/hyperlinkcolor" matchingName="標題、項目符號與照片">
-  <p:cSld name="標題、項目符號與照片">
+  <p:cSld name="CONTENT_WITH_PHOTO">
     <p:spTree>
       <p:nvGrpSpPr>
         <p:cNvPr id="74" name="Shape 74"/>
@@ -9424,7 +9424,7 @@
 
 <file path=ppt/slideLayouts/slideLayout9.xml><?xml version="1.0" encoding="utf-8"?>
 <p:sldLayout xmlns:a="http://schemas.openxmlformats.org/drawingml/2006/main" xmlns:r="http://schemas.openxmlformats.org/officeDocument/2006/relationships" xmlns:mc="http://schemas.openxmlformats.org/markup-compatibility/2006" xmlns:mv="urn:schemas-microsoft-com:mac:vml" xmlns:p="http://schemas.openxmlformats.org/presentationml/2006/main" xmlns:c="http://schemas.openxmlformats.org/drawingml/2006/chart" xmlns:dgm="http://schemas.openxmlformats.org/drawingml/2006/diagram" xmlns:o="urn:schemas-microsoft-com:office:office" xmlns:v="urn:schemas-microsoft-com:vml" xmlns:pvml="urn:schemas-microsoft-com:office:powerpoint" xmlns:com="http://schemas.openxmlformats.org/drawingml/2006/compatibility" xmlns:p14="http://schemas.microsoft.com/office/powerpoint/2010/main" xmlns:p15="http://schemas.microsoft.com/office/powerpoint/2012/main" xmlns:ahyp="http://schemas.microsoft.com/office/drawing/2018/hyperlinkcolor" matchingName="項目符號">
-  <p:cSld name="項目符號">
+  <p:cSld name="BULLET_LIST">
     <p:spTree>
       <p:nvGrpSpPr>
         <p:cNvPr id="88" name="Shape 88"/>

</xml_diff>